<commit_message>
Refine slide image scaling and generous whitespace for ultra-minimal deck
</commit_message>
<xml_diff>
--- a/Aircraft_Design_DT1_EXAELIA_Group13.pptx
+++ b/Aircraft_Design_DT1_EXAELIA_Group13.pptx
@@ -3451,8 +3451,8 @@
         </p:nvSpPr>
         <p:spPr>
           <a:xfrm>
-            <a:off x="4114800" y="1371600"/>
-            <a:ext cx="3962095" cy="4754880"/>
+            <a:off x="4297680" y="1371600"/>
+            <a:ext cx="3596335" cy="4572000"/>
           </a:xfrm>
           <a:prstGeom prst="roundRect">
             <a:avLst/>
@@ -3504,8 +3504,8 @@
         </p:blipFill>
         <p:spPr>
           <a:xfrm>
-            <a:off x="4297680" y="1508760"/>
-            <a:ext cx="3596335" cy="5083696"/>
+            <a:off x="4480560" y="1463040"/>
+            <a:ext cx="3104975" cy="4389120"/>
           </a:xfrm>
           <a:prstGeom prst="rect">
             <a:avLst/>
@@ -3520,7 +3520,7 @@
         </p:nvSpPr>
         <p:spPr>
           <a:xfrm>
-            <a:off x="822960" y="6263640"/>
+            <a:off x="822960" y="6172200"/>
             <a:ext cx="10545775" cy="320040"/>
           </a:xfrm>
           <a:prstGeom prst="rect">
@@ -3654,8 +3654,8 @@
         </p:nvSpPr>
         <p:spPr>
           <a:xfrm>
-            <a:off x="2560320" y="1371600"/>
-            <a:ext cx="7071055" cy="4663440"/>
+            <a:off x="3017520" y="1371600"/>
+            <a:ext cx="6156655" cy="4572000"/>
           </a:xfrm>
           <a:prstGeom prst="roundRect">
             <a:avLst/>
@@ -3707,8 +3707,8 @@
         </p:blipFill>
         <p:spPr>
           <a:xfrm>
-            <a:off x="2834640" y="1536192"/>
-            <a:ext cx="6522415" cy="5104499"/>
+            <a:off x="3346704" y="1508760"/>
+            <a:ext cx="5491480" cy="4297680"/>
           </a:xfrm>
           <a:prstGeom prst="rect">
             <a:avLst/>
@@ -3723,7 +3723,7 @@
         </p:nvSpPr>
         <p:spPr>
           <a:xfrm>
-            <a:off x="822960" y="6263640"/>
+            <a:off x="822960" y="6172200"/>
             <a:ext cx="10545775" cy="320040"/>
           </a:xfrm>
           <a:prstGeom prst="rect">
@@ -3858,7 +3858,7 @@
         <p:spPr>
           <a:xfrm>
             <a:off x="822960" y="1371600"/>
-            <a:ext cx="6035040" cy="4754880"/>
+            <a:ext cx="6035040" cy="4572000"/>
           </a:xfrm>
           <a:prstGeom prst="roundRect">
             <a:avLst/>
@@ -3910,7 +3910,7 @@
         </p:blipFill>
         <p:spPr>
           <a:xfrm>
-            <a:off x="1051560" y="1691640"/>
+            <a:off x="1051560" y="1600200"/>
             <a:ext cx="5577840" cy="3718560"/>
           </a:xfrm>
           <a:prstGeom prst="rect">
@@ -3927,7 +3927,7 @@
         <p:spPr>
           <a:xfrm>
             <a:off x="7132320" y="1371600"/>
-            <a:ext cx="4236415" cy="2240280"/>
+            <a:ext cx="4236415" cy="2148840"/>
           </a:xfrm>
           <a:prstGeom prst="roundRect">
             <a:avLst/>
@@ -3971,7 +3971,7 @@
         </p:nvSpPr>
         <p:spPr>
           <a:xfrm>
-            <a:off x="7406640" y="1600200"/>
+            <a:off x="7406640" y="1554480"/>
             <a:ext cx="3657600" cy="1737360"/>
           </a:xfrm>
           <a:prstGeom prst="rect">
@@ -4000,9 +4000,9 @@
           <a:p>
             <a:pPr>
               <a:spcBef>
-                <a:spcPts val="400"/>
+                <a:spcPts val="300"/>
               </a:spcBef>
-              <a:defRPr sz="3200" b="1">
+              <a:defRPr sz="3000" b="1">
                 <a:solidFill>
                   <a:srgbClr val="F8FAFC"/>
                 </a:solidFill>
@@ -4016,7 +4016,7 @@
           <a:p>
             <a:pPr>
               <a:spcBef>
-                <a:spcPts val="400"/>
+                <a:spcPts val="300"/>
               </a:spcBef>
               <a:defRPr sz="1100">
                 <a:solidFill>
@@ -4039,8 +4039,8 @@
         </p:nvSpPr>
         <p:spPr>
           <a:xfrm>
-            <a:off x="7132320" y="3886200"/>
-            <a:ext cx="4236415" cy="2240280"/>
+            <a:off x="7132320" y="3794760"/>
+            <a:ext cx="4236415" cy="2148840"/>
           </a:xfrm>
           <a:prstGeom prst="roundRect">
             <a:avLst/>
@@ -4084,7 +4084,7 @@
         </p:nvSpPr>
         <p:spPr>
           <a:xfrm>
-            <a:off x="7406640" y="4114800"/>
+            <a:off x="7406640" y="3977639"/>
             <a:ext cx="3657600" cy="1737360"/>
           </a:xfrm>
           <a:prstGeom prst="rect">
@@ -4113,9 +4113,9 @@
           <a:p>
             <a:pPr>
               <a:spcBef>
-                <a:spcPts val="400"/>
+                <a:spcPts val="300"/>
               </a:spcBef>
-              <a:defRPr sz="3600" b="1">
+              <a:defRPr sz="3400" b="1">
                 <a:solidFill>
                   <a:srgbClr val="38BDF8"/>
                 </a:solidFill>
@@ -4129,7 +4129,7 @@
           <a:p>
             <a:pPr>
               <a:spcBef>
-                <a:spcPts val="400"/>
+                <a:spcPts val="300"/>
               </a:spcBef>
               <a:defRPr sz="1100">
                 <a:solidFill>
@@ -4251,7 +4251,7 @@
         <p:spPr>
           <a:xfrm>
             <a:off x="822960" y="1371600"/>
-            <a:ext cx="5150815" cy="2240280"/>
+            <a:ext cx="5150815" cy="2148840"/>
           </a:xfrm>
           <a:prstGeom prst="roundRect">
             <a:avLst/>
@@ -4295,7 +4295,7 @@
         </p:nvSpPr>
         <p:spPr>
           <a:xfrm>
-            <a:off x="1188720" y="1691640"/>
+            <a:off x="1188720" y="1645920"/>
             <a:ext cx="4389120" cy="1600200"/>
           </a:xfrm>
           <a:prstGeom prst="rect">
@@ -4326,7 +4326,7 @@
               <a:spcBef>
                 <a:spcPts val="200"/>
               </a:spcBef>
-              <a:defRPr sz="4000" b="1">
+              <a:defRPr sz="3800" b="1">
                 <a:solidFill>
                   <a:srgbClr val="F8FAFC"/>
                 </a:solidFill>
@@ -4340,9 +4340,9 @@
           <a:p>
             <a:pPr>
               <a:spcBef>
-                <a:spcPts val="400"/>
+                <a:spcPts val="300"/>
               </a:spcBef>
-              <a:defRPr sz="1200">
+              <a:defRPr sz="1150">
                 <a:solidFill>
                   <a:srgbClr val="CBD5E1"/>
                 </a:solidFill>
@@ -4364,7 +4364,7 @@
         <p:spPr>
           <a:xfrm>
             <a:off x="6217920" y="1371600"/>
-            <a:ext cx="5150815" cy="2240280"/>
+            <a:ext cx="5150815" cy="2148840"/>
           </a:xfrm>
           <a:prstGeom prst="roundRect">
             <a:avLst/>
@@ -4408,7 +4408,7 @@
         </p:nvSpPr>
         <p:spPr>
           <a:xfrm>
-            <a:off x="6583680" y="1691640"/>
+            <a:off x="6583680" y="1645920"/>
             <a:ext cx="4389120" cy="1600200"/>
           </a:xfrm>
           <a:prstGeom prst="rect">
@@ -4439,7 +4439,7 @@
               <a:spcBef>
                 <a:spcPts val="200"/>
               </a:spcBef>
-              <a:defRPr sz="4000" b="1">
+              <a:defRPr sz="3800" b="1">
                 <a:solidFill>
                   <a:srgbClr val="38BDF8"/>
                 </a:solidFill>
@@ -4453,9 +4453,9 @@
           <a:p>
             <a:pPr>
               <a:spcBef>
-                <a:spcPts val="400"/>
+                <a:spcPts val="300"/>
               </a:spcBef>
-              <a:defRPr sz="1200">
+              <a:defRPr sz="1150">
                 <a:solidFill>
                   <a:srgbClr val="CBD5E1"/>
                 </a:solidFill>
@@ -4476,8 +4476,8 @@
         </p:nvSpPr>
         <p:spPr>
           <a:xfrm>
-            <a:off x="822960" y="3840480"/>
-            <a:ext cx="5150815" cy="2240280"/>
+            <a:off x="822960" y="3749039"/>
+            <a:ext cx="5150815" cy="2148840"/>
           </a:xfrm>
           <a:prstGeom prst="roundRect">
             <a:avLst/>
@@ -4521,7 +4521,7 @@
         </p:nvSpPr>
         <p:spPr>
           <a:xfrm>
-            <a:off x="1188720" y="4160520"/>
+            <a:off x="1188720" y="4023359"/>
             <a:ext cx="4389120" cy="1600200"/>
           </a:xfrm>
           <a:prstGeom prst="rect">
@@ -4552,7 +4552,7 @@
               <a:spcBef>
                 <a:spcPts val="200"/>
               </a:spcBef>
-              <a:defRPr sz="4000" b="1">
+              <a:defRPr sz="3800" b="1">
                 <a:solidFill>
                   <a:srgbClr val="F8FAFC"/>
                 </a:solidFill>
@@ -4566,9 +4566,9 @@
           <a:p>
             <a:pPr>
               <a:spcBef>
-                <a:spcPts val="400"/>
+                <a:spcPts val="300"/>
               </a:spcBef>
-              <a:defRPr sz="1200">
+              <a:defRPr sz="1150">
                 <a:solidFill>
                   <a:srgbClr val="CBD5E1"/>
                 </a:solidFill>
@@ -4589,8 +4589,8 @@
         </p:nvSpPr>
         <p:spPr>
           <a:xfrm>
-            <a:off x="6217920" y="3840480"/>
-            <a:ext cx="5150815" cy="2240280"/>
+            <a:off x="6217920" y="3749039"/>
+            <a:ext cx="5150815" cy="2148840"/>
           </a:xfrm>
           <a:prstGeom prst="roundRect">
             <a:avLst/>
@@ -4634,7 +4634,7 @@
         </p:nvSpPr>
         <p:spPr>
           <a:xfrm>
-            <a:off x="6583680" y="4160520"/>
+            <a:off x="6583680" y="4023359"/>
             <a:ext cx="4389120" cy="1600200"/>
           </a:xfrm>
           <a:prstGeom prst="rect">
@@ -4665,7 +4665,7 @@
               <a:spcBef>
                 <a:spcPts val="200"/>
               </a:spcBef>
-              <a:defRPr sz="4000" b="1">
+              <a:defRPr sz="3800" b="1">
                 <a:solidFill>
                   <a:srgbClr val="38BDF8"/>
                 </a:solidFill>
@@ -4679,9 +4679,9 @@
           <a:p>
             <a:pPr>
               <a:spcBef>
-                <a:spcPts val="400"/>
+                <a:spcPts val="300"/>
               </a:spcBef>
-              <a:defRPr sz="1200">
+              <a:defRPr sz="1150">
                 <a:solidFill>
                   <a:srgbClr val="CBD5E1"/>
                 </a:solidFill>
@@ -4800,8 +4800,8 @@
         </p:nvSpPr>
         <p:spPr>
           <a:xfrm>
-            <a:off x="822960" y="1463040"/>
-            <a:ext cx="3413455" cy="4663440"/>
+            <a:off x="822960" y="1371600"/>
+            <a:ext cx="3413455" cy="4572000"/>
           </a:xfrm>
           <a:prstGeom prst="roundRect">
             <a:avLst/>
@@ -4845,8 +4845,8 @@
         </p:nvSpPr>
         <p:spPr>
           <a:xfrm>
-            <a:off x="1143000" y="1828800"/>
-            <a:ext cx="2743200" cy="3931920"/>
+            <a:off x="1143000" y="1737360"/>
+            <a:ext cx="2743200" cy="3840480"/>
           </a:xfrm>
           <a:prstGeom prst="rect">
             <a:avLst/>
@@ -4929,8 +4929,8 @@
         </p:nvSpPr>
         <p:spPr>
           <a:xfrm>
-            <a:off x="4389120" y="1463040"/>
-            <a:ext cx="3413455" cy="4663440"/>
+            <a:off x="4389120" y="1371600"/>
+            <a:ext cx="3413455" cy="4572000"/>
           </a:xfrm>
           <a:prstGeom prst="roundRect">
             <a:avLst/>
@@ -4974,8 +4974,8 @@
         </p:nvSpPr>
         <p:spPr>
           <a:xfrm>
-            <a:off x="4709160" y="1828800"/>
-            <a:ext cx="2743200" cy="3931920"/>
+            <a:off x="4709160" y="1737360"/>
+            <a:ext cx="2743200" cy="3840480"/>
           </a:xfrm>
           <a:prstGeom prst="rect">
             <a:avLst/>
@@ -5058,8 +5058,8 @@
         </p:nvSpPr>
         <p:spPr>
           <a:xfrm>
-            <a:off x="7955279" y="1463040"/>
-            <a:ext cx="3413455" cy="4663440"/>
+            <a:off x="7955279" y="1371600"/>
+            <a:ext cx="3413455" cy="4572000"/>
           </a:xfrm>
           <a:prstGeom prst="roundRect">
             <a:avLst/>
@@ -5103,8 +5103,8 @@
         </p:nvSpPr>
         <p:spPr>
           <a:xfrm>
-            <a:off x="8275319" y="1828800"/>
-            <a:ext cx="2743200" cy="3931920"/>
+            <a:off x="8275319" y="1737360"/>
+            <a:ext cx="2743200" cy="3840480"/>
           </a:xfrm>
           <a:prstGeom prst="rect">
             <a:avLst/>
@@ -5285,8 +5285,8 @@
         </p:nvSpPr>
         <p:spPr>
           <a:xfrm>
-            <a:off x="2011680" y="1371600"/>
-            <a:ext cx="8168335" cy="4754880"/>
+            <a:off x="2743200" y="1371600"/>
+            <a:ext cx="6705295" cy="4572000"/>
           </a:xfrm>
           <a:prstGeom prst="roundRect">
             <a:avLst/>
@@ -5338,8 +5338,8 @@
         </p:blipFill>
         <p:spPr>
           <a:xfrm>
-            <a:off x="2240280" y="1508760"/>
-            <a:ext cx="7711135" cy="5757647"/>
+            <a:off x="3154680" y="1463040"/>
+            <a:ext cx="5878286" cy="4389120"/>
           </a:xfrm>
           <a:prstGeom prst="rect">
             <a:avLst/>
@@ -5354,7 +5354,7 @@
         </p:nvSpPr>
         <p:spPr>
           <a:xfrm>
-            <a:off x="822960" y="6263640"/>
+            <a:off x="822960" y="6172200"/>
             <a:ext cx="10545775" cy="320040"/>
           </a:xfrm>
           <a:prstGeom prst="rect">
@@ -5488,8 +5488,8 @@
         </p:nvSpPr>
         <p:spPr>
           <a:xfrm>
-            <a:off x="2011680" y="1371600"/>
-            <a:ext cx="8168335" cy="4754880"/>
+            <a:off x="2651760" y="1371600"/>
+            <a:ext cx="6888175" cy="4572000"/>
           </a:xfrm>
           <a:prstGeom prst="roundRect">
             <a:avLst/>
@@ -5541,8 +5541,8 @@
         </p:blipFill>
         <p:spPr>
           <a:xfrm>
-            <a:off x="2240280" y="1508760"/>
-            <a:ext cx="7711135" cy="5478964"/>
+            <a:off x="3008376" y="1463040"/>
+            <a:ext cx="6177280" cy="4389120"/>
           </a:xfrm>
           <a:prstGeom prst="rect">
             <a:avLst/>
@@ -5557,7 +5557,7 @@
         </p:nvSpPr>
         <p:spPr>
           <a:xfrm>
-            <a:off x="822960" y="6263640"/>
+            <a:off x="822960" y="6172200"/>
             <a:ext cx="10545775" cy="320040"/>
           </a:xfrm>
           <a:prstGeom prst="rect">

</xml_diff>

<commit_message>
Restore 100% authentic original course graphs in clean minimalist black & white theme
</commit_message>
<xml_diff>
--- a/Aircraft_Design_DT1_EXAELIA_Group13.pptx
+++ b/Aircraft_Design_DT1_EXAELIA_Group13.pptx
@@ -3091,7 +3091,7 @@
     <p:bg>
       <p:bgPr>
         <a:solidFill>
-          <a:srgbClr val="000000"/>
+          <a:srgbClr val="FFFFFF"/>
         </a:solidFill>
         <a:effectLst/>
       </p:bgPr>
@@ -3128,7 +3128,7 @@
             <a:pPr>
               <a:defRPr sz="1100" b="1">
                 <a:solidFill>
-                  <a:srgbClr val="A1A1AA"/>
+                  <a:srgbClr val="64748B"/>
                 </a:solidFill>
                 <a:latin typeface="Arial"/>
               </a:defRPr>
@@ -3164,7 +3164,7 @@
             <a:pPr>
               <a:defRPr sz="4800" b="1">
                 <a:solidFill>
-                  <a:srgbClr val="FFFFFF"/>
+                  <a:srgbClr val="0F172A"/>
                 </a:solidFill>
                 <a:latin typeface="Helvetica Neue"/>
               </a:defRPr>
@@ -3200,7 +3200,7 @@
             <a:pPr>
               <a:defRPr sz="1800">
                 <a:solidFill>
-                  <a:srgbClr val="E4E4E7"/>
+                  <a:srgbClr val="334155"/>
                 </a:solidFill>
                 <a:latin typeface="Helvetica Neue"/>
               </a:defRPr>
@@ -3236,7 +3236,7 @@
             <a:pPr>
               <a:defRPr sz="1400" b="1">
                 <a:solidFill>
-                  <a:srgbClr val="FFFFFF"/>
+                  <a:srgbClr val="0F172A"/>
                 </a:solidFill>
                 <a:latin typeface="Arial"/>
               </a:defRPr>
@@ -3252,7 +3252,7 @@
               </a:spcBef>
               <a:defRPr sz="1300" b="1">
                 <a:solidFill>
-                  <a:srgbClr val="A1A1AA"/>
+                  <a:srgbClr val="64748B"/>
                 </a:solidFill>
                 <a:latin typeface="Arial"/>
               </a:defRPr>
@@ -3278,11 +3278,11 @@
             <a:avLst/>
           </a:prstGeom>
           <a:solidFill>
-            <a:srgbClr val="121214"/>
+            <a:srgbClr val="F8FAFC"/>
           </a:solidFill>
           <a:ln w="9525">
             <a:solidFill>
-              <a:srgbClr val="27272A"/>
+              <a:srgbClr val="E2E8F0"/>
             </a:solidFill>
           </a:ln>
         </p:spPr>
@@ -3333,7 +3333,7 @@
             <a:pPr algn="ctr">
               <a:defRPr sz="1250" b="1">
                 <a:solidFill>
-                  <a:srgbClr val="FFFFFF"/>
+                  <a:srgbClr val="0F172A"/>
                 </a:solidFill>
                 <a:latin typeface="Arial"/>
               </a:defRPr>
@@ -3358,7 +3358,7 @@
     <p:bg>
       <p:bgPr>
         <a:solidFill>
-          <a:srgbClr val="000000"/>
+          <a:srgbClr val="FFFFFF"/>
         </a:solidFill>
         <a:effectLst/>
       </p:bgPr>
@@ -3395,7 +3395,7 @@
             <a:pPr>
               <a:defRPr sz="950" b="1">
                 <a:solidFill>
-                  <a:srgbClr val="A1A1AA"/>
+                  <a:srgbClr val="64748B"/>
                 </a:solidFill>
                 <a:latin typeface="Arial"/>
               </a:defRPr>
@@ -3431,7 +3431,7 @@
             <a:pPr>
               <a:defRPr sz="2400" b="1">
                 <a:solidFill>
-                  <a:srgbClr val="FFFFFF"/>
+                  <a:srgbClr val="0F172A"/>
                 </a:solidFill>
                 <a:latin typeface="Helvetica Neue"/>
               </a:defRPr>
@@ -3439,12 +3439,57 @@
             <a:r>
               <a:t>Blended wing body</a:t>
             </a:r>
+          </a:p>
+        </p:txBody>
+      </p:sp>
+      <p:sp>
+        <p:nvSpPr>
+          <p:cNvPr id="4" name="Rounded Rectangle 3"/>
+          <p:cNvSpPr/>
+          <p:nvPr/>
+        </p:nvSpPr>
+        <p:spPr>
+          <a:xfrm>
+            <a:off x="4114800" y="1280160"/>
+            <a:ext cx="3962095" cy="4846320"/>
+          </a:xfrm>
+          <a:prstGeom prst="roundRect">
+            <a:avLst/>
+          </a:prstGeom>
+          <a:solidFill>
+            <a:srgbClr val="F8FAFC"/>
+          </a:solidFill>
+          <a:ln w="9525">
+            <a:solidFill>
+              <a:srgbClr val="E2E8F0"/>
+            </a:solidFill>
+          </a:ln>
+        </p:spPr>
+        <p:style>
+          <a:lnRef idx="1">
+            <a:schemeClr val="accent1"/>
+          </a:lnRef>
+          <a:fillRef idx="3">
+            <a:schemeClr val="accent1"/>
+          </a:fillRef>
+          <a:effectRef idx="2">
+            <a:schemeClr val="accent1"/>
+          </a:effectRef>
+          <a:fontRef idx="minor">
+            <a:schemeClr val="lt1"/>
+          </a:fontRef>
+        </p:style>
+        <p:txBody>
+          <a:bodyPr rtlCol="0" anchor="ctr"/>
+          <a:lstStyle/>
+          <a:p>
+            <a:pPr algn="ctr"/>
           </a:p>
         </p:txBody>
       </p:sp>
       <p:pic>
         <p:nvPicPr>
-          <p:cNvPr id="4" name="Picture 3" descr="slide2_sketch_bw.png"/>
+          <p:cNvPr id="5" name="Picture 4" descr="slide_2_Content Placeholder 4.jpg"/>
           <p:cNvPicPr>
             <a:picLocks noChangeAspect="1"/>
           </p:cNvPicPr>
@@ -3458,7 +3503,7 @@
         </p:blipFill>
         <p:spPr>
           <a:xfrm>
-            <a:off x="4389120" y="1325880"/>
+            <a:off x="4443984" y="1371600"/>
             <a:ext cx="3299036" cy="4663440"/>
           </a:xfrm>
           <a:prstGeom prst="rect">
@@ -3468,13 +3513,13 @@
       </p:pic>
       <p:sp>
         <p:nvSpPr>
-          <p:cNvPr id="5" name="TextBox 4"/>
+          <p:cNvPr id="6" name="TextBox 5"/>
           <p:cNvSpPr txBox="1"/>
           <p:nvPr/>
         </p:nvSpPr>
         <p:spPr>
           <a:xfrm>
-            <a:off x="822960" y="6217920"/>
+            <a:off x="822960" y="6263640"/>
             <a:ext cx="10545775" cy="320040"/>
           </a:xfrm>
           <a:prstGeom prst="rect">
@@ -3491,7 +3536,7 @@
             <a:pPr algn="ctr">
               <a:defRPr sz="1100">
                 <a:solidFill>
-                  <a:srgbClr val="A1A1AA"/>
+                  <a:srgbClr val="64748B"/>
                 </a:solidFill>
                 <a:latin typeface="Arial"/>
               </a:defRPr>
@@ -3516,7 +3561,7 @@
     <p:bg>
       <p:bgPr>
         <a:solidFill>
-          <a:srgbClr val="000000"/>
+          <a:srgbClr val="FFFFFF"/>
         </a:solidFill>
         <a:effectLst/>
       </p:bgPr>
@@ -3553,7 +3598,7 @@
             <a:pPr>
               <a:defRPr sz="950" b="1">
                 <a:solidFill>
-                  <a:srgbClr val="A1A1AA"/>
+                  <a:srgbClr val="64748B"/>
                 </a:solidFill>
                 <a:latin typeface="Arial"/>
               </a:defRPr>
@@ -3589,7 +3634,7 @@
             <a:pPr>
               <a:defRPr sz="2400" b="1">
                 <a:solidFill>
-                  <a:srgbClr val="FFFFFF"/>
+                  <a:srgbClr val="0F172A"/>
                 </a:solidFill>
                 <a:latin typeface="Helvetica Neue"/>
               </a:defRPr>
@@ -3602,7 +3647,7 @@
       </p:sp>
       <p:pic>
         <p:nvPicPr>
-          <p:cNvPr id="4" name="Picture 3" descr="slide3_mission_bw.png"/>
+          <p:cNvPr id="4" name="Picture 3" descr="slide_3_Content Placeholder 8.jpg"/>
           <p:cNvPicPr>
             <a:picLocks noChangeAspect="1"/>
           </p:cNvPicPr>
@@ -3616,8 +3661,8 @@
         </p:blipFill>
         <p:spPr>
           <a:xfrm>
-            <a:off x="1280160" y="1325880"/>
-            <a:ext cx="9631375" cy="4402914"/>
+            <a:off x="3236976" y="1325880"/>
+            <a:ext cx="5725160" cy="4480560"/>
           </a:xfrm>
           <a:prstGeom prst="rect">
             <a:avLst/>
@@ -3632,7 +3677,7 @@
         </p:nvSpPr>
         <p:spPr>
           <a:xfrm>
-            <a:off x="822960" y="6217920"/>
+            <a:off x="822960" y="6263640"/>
             <a:ext cx="10545775" cy="320040"/>
           </a:xfrm>
           <a:prstGeom prst="rect">
@@ -3649,7 +3694,7 @@
             <a:pPr algn="ctr">
               <a:defRPr sz="1100">
                 <a:solidFill>
-                  <a:srgbClr val="A1A1AA"/>
+                  <a:srgbClr val="64748B"/>
                 </a:solidFill>
                 <a:latin typeface="Arial"/>
               </a:defRPr>
@@ -3674,7 +3719,7 @@
     <p:bg>
       <p:bgPr>
         <a:solidFill>
-          <a:srgbClr val="000000"/>
+          <a:srgbClr val="FFFFFF"/>
         </a:solidFill>
         <a:effectLst/>
       </p:bgPr>
@@ -3711,7 +3756,7 @@
             <a:pPr>
               <a:defRPr sz="950" b="1">
                 <a:solidFill>
-                  <a:srgbClr val="A1A1AA"/>
+                  <a:srgbClr val="64748B"/>
                 </a:solidFill>
                 <a:latin typeface="Arial"/>
               </a:defRPr>
@@ -3747,7 +3792,7 @@
             <a:pPr>
               <a:defRPr sz="2400" b="1">
                 <a:solidFill>
-                  <a:srgbClr val="FFFFFF"/>
+                  <a:srgbClr val="0F172A"/>
                 </a:solidFill>
                 <a:latin typeface="Helvetica Neue"/>
               </a:defRPr>
@@ -3760,7 +3805,7 @@
       </p:sp>
       <p:pic>
         <p:nvPicPr>
-          <p:cNvPr id="4" name="Picture 3" descr="slide4_sfc_bw.png"/>
+          <p:cNvPr id="4" name="Picture 3" descr="slide_4_Picture 6.png"/>
           <p:cNvPicPr>
             <a:picLocks noChangeAspect="1"/>
           </p:cNvPicPr>
@@ -3774,8 +3819,8 @@
         </p:blipFill>
         <p:spPr>
           <a:xfrm>
-            <a:off x="822960" y="1325880"/>
-            <a:ext cx="6217920" cy="4318000"/>
+            <a:off x="822960" y="1463040"/>
+            <a:ext cx="6217920" cy="4145280"/>
           </a:xfrm>
           <a:prstGeom prst="rect">
             <a:avLst/>
@@ -3790,18 +3835,18 @@
         </p:nvSpPr>
         <p:spPr>
           <a:xfrm>
-            <a:off x="7315200" y="1371600"/>
-            <a:ext cx="4053535" cy="2194560"/>
+            <a:off x="7315200" y="1463040"/>
+            <a:ext cx="4053535" cy="2148840"/>
           </a:xfrm>
           <a:prstGeom prst="roundRect">
             <a:avLst/>
           </a:prstGeom>
           <a:solidFill>
-            <a:srgbClr val="121214"/>
+            <a:srgbClr val="F8FAFC"/>
           </a:solidFill>
           <a:ln w="9525">
             <a:solidFill>
-              <a:srgbClr val="27272A"/>
+              <a:srgbClr val="E2E8F0"/>
             </a:solidFill>
           </a:ln>
         </p:spPr>
@@ -3835,8 +3880,8 @@
         </p:nvSpPr>
         <p:spPr>
           <a:xfrm>
-            <a:off x="7589520" y="1600200"/>
-            <a:ext cx="3474720" cy="1737360"/>
+            <a:off x="7589520" y="1691640"/>
+            <a:ext cx="3474720" cy="1691640"/>
           </a:xfrm>
           <a:prstGeom prst="rect">
             <a:avLst/>
@@ -3852,7 +3897,7 @@
             <a:pPr>
               <a:defRPr sz="1100" b="1">
                 <a:solidFill>
-                  <a:srgbClr val="A1A1AA"/>
+                  <a:srgbClr val="64748B"/>
                 </a:solidFill>
                 <a:latin typeface="Arial"/>
               </a:defRPr>
@@ -3868,7 +3913,7 @@
               </a:spcBef>
               <a:defRPr sz="2800" b="1">
                 <a:solidFill>
-                  <a:srgbClr val="FFFFFF"/>
+                  <a:srgbClr val="0F172A"/>
                 </a:solidFill>
                 <a:latin typeface="Helvetica Neue"/>
               </a:defRPr>
@@ -3884,7 +3929,7 @@
               </a:spcBef>
               <a:defRPr sz="1100">
                 <a:solidFill>
-                  <a:srgbClr val="E4E4E7"/>
+                  <a:srgbClr val="334155"/>
                 </a:solidFill>
                 <a:latin typeface="Arial"/>
               </a:defRPr>
@@ -3904,17 +3949,17 @@
         <p:spPr>
           <a:xfrm>
             <a:off x="7315200" y="3794760"/>
-            <a:ext cx="4053535" cy="2194560"/>
+            <a:ext cx="4053535" cy="2148840"/>
           </a:xfrm>
           <a:prstGeom prst="roundRect">
             <a:avLst/>
           </a:prstGeom>
           <a:solidFill>
-            <a:srgbClr val="121214"/>
+            <a:srgbClr val="F8FAFC"/>
           </a:solidFill>
           <a:ln w="9525">
             <a:solidFill>
-              <a:srgbClr val="27272A"/>
+              <a:srgbClr val="E2E8F0"/>
             </a:solidFill>
           </a:ln>
         </p:spPr>
@@ -3949,7 +3994,7 @@
         <p:spPr>
           <a:xfrm>
             <a:off x="7589520" y="4023360"/>
-            <a:ext cx="3474720" cy="1737360"/>
+            <a:ext cx="3474720" cy="1691640"/>
           </a:xfrm>
           <a:prstGeom prst="rect">
             <a:avLst/>
@@ -3965,7 +4010,7 @@
             <a:pPr>
               <a:defRPr sz="1100" b="1">
                 <a:solidFill>
-                  <a:srgbClr val="A1A1AA"/>
+                  <a:srgbClr val="64748B"/>
                 </a:solidFill>
                 <a:latin typeface="Arial"/>
               </a:defRPr>
@@ -3981,7 +4026,7 @@
               </a:spcBef>
               <a:defRPr sz="3200" b="1">
                 <a:solidFill>
-                  <a:srgbClr val="FFFFFF"/>
+                  <a:srgbClr val="0F172A"/>
                 </a:solidFill>
                 <a:latin typeface="Helvetica Neue"/>
               </a:defRPr>
@@ -3997,7 +4042,7 @@
               </a:spcBef>
               <a:defRPr sz="1100">
                 <a:solidFill>
-                  <a:srgbClr val="E4E4E7"/>
+                  <a:srgbClr val="334155"/>
                 </a:solidFill>
                 <a:latin typeface="Arial"/>
               </a:defRPr>
@@ -4022,7 +4067,7 @@
     <p:bg>
       <p:bgPr>
         <a:solidFill>
-          <a:srgbClr val="000000"/>
+          <a:srgbClr val="FFFFFF"/>
         </a:solidFill>
         <a:effectLst/>
       </p:bgPr>
@@ -4059,7 +4104,7 @@
             <a:pPr>
               <a:defRPr sz="950" b="1">
                 <a:solidFill>
-                  <a:srgbClr val="A1A1AA"/>
+                  <a:srgbClr val="64748B"/>
                 </a:solidFill>
                 <a:latin typeface="Arial"/>
               </a:defRPr>
@@ -4095,7 +4140,7 @@
             <a:pPr>
               <a:defRPr sz="2400" b="1">
                 <a:solidFill>
-                  <a:srgbClr val="FFFFFF"/>
+                  <a:srgbClr val="0F172A"/>
                 </a:solidFill>
                 <a:latin typeface="Helvetica Neue"/>
               </a:defRPr>
@@ -4121,11 +4166,11 @@
             <a:avLst/>
           </a:prstGeom>
           <a:solidFill>
-            <a:srgbClr val="121214"/>
+            <a:srgbClr val="F8FAFC"/>
           </a:solidFill>
           <a:ln w="9525">
             <a:solidFill>
-              <a:srgbClr val="27272A"/>
+              <a:srgbClr val="E2E8F0"/>
             </a:solidFill>
           </a:ln>
         </p:spPr>
@@ -4176,7 +4221,7 @@
             <a:pPr>
               <a:defRPr sz="1100" b="1">
                 <a:solidFill>
-                  <a:srgbClr val="A1A1AA"/>
+                  <a:srgbClr val="64748B"/>
                 </a:solidFill>
                 <a:latin typeface="Arial"/>
               </a:defRPr>
@@ -4190,9 +4235,9 @@
               <a:spcBef>
                 <a:spcPts val="200"/>
               </a:spcBef>
-              <a:defRPr sz="4000" b="1">
-                <a:solidFill>
-                  <a:srgbClr val="FFFFFF"/>
+              <a:defRPr sz="4200" b="1">
+                <a:solidFill>
+                  <a:srgbClr val="0F172A"/>
                 </a:solidFill>
                 <a:latin typeface="Helvetica Neue"/>
               </a:defRPr>
@@ -4208,7 +4253,7 @@
               </a:spcBef>
               <a:defRPr sz="1150">
                 <a:solidFill>
-                  <a:srgbClr val="E4E4E7"/>
+                  <a:srgbClr val="334155"/>
                 </a:solidFill>
                 <a:latin typeface="Arial"/>
               </a:defRPr>
@@ -4234,11 +4279,11 @@
             <a:avLst/>
           </a:prstGeom>
           <a:solidFill>
-            <a:srgbClr val="121214"/>
+            <a:srgbClr val="F8FAFC"/>
           </a:solidFill>
           <a:ln w="9525">
             <a:solidFill>
-              <a:srgbClr val="27272A"/>
+              <a:srgbClr val="E2E8F0"/>
             </a:solidFill>
           </a:ln>
         </p:spPr>
@@ -4289,7 +4334,7 @@
             <a:pPr>
               <a:defRPr sz="1100" b="1">
                 <a:solidFill>
-                  <a:srgbClr val="A1A1AA"/>
+                  <a:srgbClr val="64748B"/>
                 </a:solidFill>
                 <a:latin typeface="Arial"/>
               </a:defRPr>
@@ -4303,9 +4348,9 @@
               <a:spcBef>
                 <a:spcPts val="200"/>
               </a:spcBef>
-              <a:defRPr sz="4000" b="1">
-                <a:solidFill>
-                  <a:srgbClr val="FFFFFF"/>
+              <a:defRPr sz="4200" b="1">
+                <a:solidFill>
+                  <a:srgbClr val="0F172A"/>
                 </a:solidFill>
                 <a:latin typeface="Helvetica Neue"/>
               </a:defRPr>
@@ -4321,7 +4366,7 @@
               </a:spcBef>
               <a:defRPr sz="1150">
                 <a:solidFill>
-                  <a:srgbClr val="E4E4E7"/>
+                  <a:srgbClr val="334155"/>
                 </a:solidFill>
                 <a:latin typeface="Arial"/>
               </a:defRPr>
@@ -4347,11 +4392,11 @@
             <a:avLst/>
           </a:prstGeom>
           <a:solidFill>
-            <a:srgbClr val="121214"/>
+            <a:srgbClr val="F8FAFC"/>
           </a:solidFill>
           <a:ln w="9525">
             <a:solidFill>
-              <a:srgbClr val="27272A"/>
+              <a:srgbClr val="E2E8F0"/>
             </a:solidFill>
           </a:ln>
         </p:spPr>
@@ -4402,7 +4447,7 @@
             <a:pPr>
               <a:defRPr sz="1100" b="1">
                 <a:solidFill>
-                  <a:srgbClr val="A1A1AA"/>
+                  <a:srgbClr val="64748B"/>
                 </a:solidFill>
                 <a:latin typeface="Arial"/>
               </a:defRPr>
@@ -4416,9 +4461,9 @@
               <a:spcBef>
                 <a:spcPts val="200"/>
               </a:spcBef>
-              <a:defRPr sz="4000" b="1">
-                <a:solidFill>
-                  <a:srgbClr val="FFFFFF"/>
+              <a:defRPr sz="4200" b="1">
+                <a:solidFill>
+                  <a:srgbClr val="0F172A"/>
                 </a:solidFill>
                 <a:latin typeface="Helvetica Neue"/>
               </a:defRPr>
@@ -4434,7 +4479,7 @@
               </a:spcBef>
               <a:defRPr sz="1150">
                 <a:solidFill>
-                  <a:srgbClr val="E4E4E7"/>
+                  <a:srgbClr val="334155"/>
                 </a:solidFill>
                 <a:latin typeface="Arial"/>
               </a:defRPr>
@@ -4460,11 +4505,11 @@
             <a:avLst/>
           </a:prstGeom>
           <a:solidFill>
-            <a:srgbClr val="121214"/>
+            <a:srgbClr val="F8FAFC"/>
           </a:solidFill>
           <a:ln w="9525">
             <a:solidFill>
-              <a:srgbClr val="27272A"/>
+              <a:srgbClr val="E2E8F0"/>
             </a:solidFill>
           </a:ln>
         </p:spPr>
@@ -4515,7 +4560,7 @@
             <a:pPr>
               <a:defRPr sz="1100" b="1">
                 <a:solidFill>
-                  <a:srgbClr val="A1A1AA"/>
+                  <a:srgbClr val="64748B"/>
                 </a:solidFill>
                 <a:latin typeface="Arial"/>
               </a:defRPr>
@@ -4529,9 +4574,9 @@
               <a:spcBef>
                 <a:spcPts val="200"/>
               </a:spcBef>
-              <a:defRPr sz="4000" b="1">
-                <a:solidFill>
-                  <a:srgbClr val="FFFFFF"/>
+              <a:defRPr sz="4200" b="1">
+                <a:solidFill>
+                  <a:srgbClr val="0F172A"/>
                 </a:solidFill>
                 <a:latin typeface="Helvetica Neue"/>
               </a:defRPr>
@@ -4547,7 +4592,7 @@
               </a:spcBef>
               <a:defRPr sz="1150">
                 <a:solidFill>
-                  <a:srgbClr val="E4E4E7"/>
+                  <a:srgbClr val="334155"/>
                 </a:solidFill>
                 <a:latin typeface="Arial"/>
               </a:defRPr>
@@ -4566,7 +4611,7 @@
         </p:nvSpPr>
         <p:spPr>
           <a:xfrm>
-            <a:off x="822960" y="6217920"/>
+            <a:off x="822960" y="6263640"/>
             <a:ext cx="10545775" cy="320040"/>
           </a:xfrm>
           <a:prstGeom prst="rect">
@@ -4583,7 +4628,7 @@
             <a:pPr algn="ctr">
               <a:defRPr sz="1100">
                 <a:solidFill>
-                  <a:srgbClr val="A1A1AA"/>
+                  <a:srgbClr val="64748B"/>
                 </a:solidFill>
                 <a:latin typeface="Arial"/>
               </a:defRPr>
@@ -4608,7 +4653,7 @@
     <p:bg>
       <p:bgPr>
         <a:solidFill>
-          <a:srgbClr val="000000"/>
+          <a:srgbClr val="FFFFFF"/>
         </a:solidFill>
         <a:effectLst/>
       </p:bgPr>
@@ -4645,7 +4690,7 @@
             <a:pPr>
               <a:defRPr sz="950" b="1">
                 <a:solidFill>
-                  <a:srgbClr val="A1A1AA"/>
+                  <a:srgbClr val="64748B"/>
                 </a:solidFill>
                 <a:latin typeface="Arial"/>
               </a:defRPr>
@@ -4681,7 +4726,7 @@
             <a:pPr>
               <a:defRPr sz="2400" b="1">
                 <a:solidFill>
-                  <a:srgbClr val="FFFFFF"/>
+                  <a:srgbClr val="0F172A"/>
                 </a:solidFill>
                 <a:latin typeface="Helvetica Neue"/>
               </a:defRPr>
@@ -4707,11 +4752,11 @@
             <a:avLst/>
           </a:prstGeom>
           <a:solidFill>
-            <a:srgbClr val="121214"/>
+            <a:srgbClr val="F8FAFC"/>
           </a:solidFill>
           <a:ln w="9525">
             <a:solidFill>
-              <a:srgbClr val="27272A"/>
+              <a:srgbClr val="E2E8F0"/>
             </a:solidFill>
           </a:ln>
         </p:spPr>
@@ -4762,7 +4807,7 @@
             <a:pPr>
               <a:defRPr sz="1100" b="1">
                 <a:solidFill>
-                  <a:srgbClr val="A1A1AA"/>
+                  <a:srgbClr val="64748B"/>
                 </a:solidFill>
                 <a:latin typeface="Arial"/>
               </a:defRPr>
@@ -4776,9 +4821,9 @@
               <a:spcBef>
                 <a:spcPts val="800"/>
               </a:spcBef>
-              <a:defRPr sz="2800" b="1">
-                <a:solidFill>
-                  <a:srgbClr val="FFFFFF"/>
+              <a:defRPr sz="2600" b="1">
+                <a:solidFill>
+                  <a:srgbClr val="0F172A"/>
                 </a:solidFill>
                 <a:latin typeface="Helvetica Neue"/>
               </a:defRPr>
@@ -4794,7 +4839,7 @@
               </a:spcBef>
               <a:defRPr sz="1350" b="1">
                 <a:solidFill>
-                  <a:srgbClr val="E4E4E7"/>
+                  <a:srgbClr val="334155"/>
                 </a:solidFill>
                 <a:latin typeface="Helvetica Neue"/>
               </a:defRPr>
@@ -4810,7 +4855,7 @@
               </a:spcBef>
               <a:defRPr sz="1100">
                 <a:solidFill>
-                  <a:srgbClr val="71717A"/>
+                  <a:srgbClr val="94A3B8"/>
                 </a:solidFill>
                 <a:latin typeface="Arial"/>
               </a:defRPr>
@@ -4836,11 +4881,11 @@
             <a:avLst/>
           </a:prstGeom>
           <a:solidFill>
-            <a:srgbClr val="121214"/>
+            <a:srgbClr val="F8FAFC"/>
           </a:solidFill>
           <a:ln w="9525">
             <a:solidFill>
-              <a:srgbClr val="27272A"/>
+              <a:srgbClr val="E2E8F0"/>
             </a:solidFill>
           </a:ln>
         </p:spPr>
@@ -4891,7 +4936,7 @@
             <a:pPr>
               <a:defRPr sz="1100" b="1">
                 <a:solidFill>
-                  <a:srgbClr val="A1A1AA"/>
+                  <a:srgbClr val="64748B"/>
                 </a:solidFill>
                 <a:latin typeface="Arial"/>
               </a:defRPr>
@@ -4907,7 +4952,7 @@
               </a:spcBef>
               <a:defRPr sz="3800" b="1">
                 <a:solidFill>
-                  <a:srgbClr val="FFFFFF"/>
+                  <a:srgbClr val="0F172A"/>
                 </a:solidFill>
                 <a:latin typeface="Helvetica Neue"/>
               </a:defRPr>
@@ -4923,7 +4968,7 @@
               </a:spcBef>
               <a:defRPr sz="1350" b="1">
                 <a:solidFill>
-                  <a:srgbClr val="E4E4E7"/>
+                  <a:srgbClr val="334155"/>
                 </a:solidFill>
                 <a:latin typeface="Helvetica Neue"/>
               </a:defRPr>
@@ -4939,7 +4984,7 @@
               </a:spcBef>
               <a:defRPr sz="1100">
                 <a:solidFill>
-                  <a:srgbClr val="71717A"/>
+                  <a:srgbClr val="94A3B8"/>
                 </a:solidFill>
                 <a:latin typeface="Arial"/>
               </a:defRPr>
@@ -4965,11 +5010,11 @@
             <a:avLst/>
           </a:prstGeom>
           <a:solidFill>
-            <a:srgbClr val="121214"/>
+            <a:srgbClr val="F8FAFC"/>
           </a:solidFill>
           <a:ln w="9525">
             <a:solidFill>
-              <a:srgbClr val="27272A"/>
+              <a:srgbClr val="E2E8F0"/>
             </a:solidFill>
           </a:ln>
         </p:spPr>
@@ -5020,7 +5065,7 @@
             <a:pPr>
               <a:defRPr sz="1100" b="1">
                 <a:solidFill>
-                  <a:srgbClr val="A1A1AA"/>
+                  <a:srgbClr val="64748B"/>
                 </a:solidFill>
                 <a:latin typeface="Arial"/>
               </a:defRPr>
@@ -5036,7 +5081,7 @@
               </a:spcBef>
               <a:defRPr sz="3800" b="1">
                 <a:solidFill>
-                  <a:srgbClr val="FFFFFF"/>
+                  <a:srgbClr val="0F172A"/>
                 </a:solidFill>
                 <a:latin typeface="Helvetica Neue"/>
               </a:defRPr>
@@ -5052,7 +5097,7 @@
               </a:spcBef>
               <a:defRPr sz="1350" b="1">
                 <a:solidFill>
-                  <a:srgbClr val="E4E4E7"/>
+                  <a:srgbClr val="334155"/>
                 </a:solidFill>
                 <a:latin typeface="Helvetica Neue"/>
               </a:defRPr>
@@ -5068,7 +5113,7 @@
               </a:spcBef>
               <a:defRPr sz="1100">
                 <a:solidFill>
-                  <a:srgbClr val="71717A"/>
+                  <a:srgbClr val="94A3B8"/>
                 </a:solidFill>
                 <a:latin typeface="Arial"/>
               </a:defRPr>
@@ -5093,7 +5138,7 @@
     <p:bg>
       <p:bgPr>
         <a:solidFill>
-          <a:srgbClr val="000000"/>
+          <a:srgbClr val="FFFFFF"/>
         </a:solidFill>
         <a:effectLst/>
       </p:bgPr>
@@ -5130,7 +5175,7 @@
             <a:pPr>
               <a:defRPr sz="950" b="1">
                 <a:solidFill>
-                  <a:srgbClr val="A1A1AA"/>
+                  <a:srgbClr val="64748B"/>
                 </a:solidFill>
                 <a:latin typeface="Arial"/>
               </a:defRPr>
@@ -5166,7 +5211,7 @@
             <a:pPr>
               <a:defRPr sz="2400" b="1">
                 <a:solidFill>
-                  <a:srgbClr val="FFFFFF"/>
+                  <a:srgbClr val="0F172A"/>
                 </a:solidFill>
                 <a:latin typeface="Helvetica Neue"/>
               </a:defRPr>
@@ -5185,7 +5230,7 @@
         </p:nvSpPr>
         <p:spPr>
           <a:xfrm>
-            <a:off x="822960" y="1234440"/>
+            <a:off x="822960" y="1188720"/>
             <a:ext cx="10515600" cy="320040"/>
           </a:xfrm>
           <a:prstGeom prst="rect">
@@ -5202,7 +5247,7 @@
             <a:pPr>
               <a:defRPr sz="1100" b="1">
                 <a:solidFill>
-                  <a:srgbClr val="A1A1AA"/>
+                  <a:srgbClr val="64748B"/>
                 </a:solidFill>
                 <a:latin typeface="Arial"/>
               </a:defRPr>
@@ -5215,7 +5260,7 @@
       </p:sp>
       <p:pic>
         <p:nvPicPr>
-          <p:cNvPr id="5" name="Picture 4" descr="slide7_concept_bw.png"/>
+          <p:cNvPr id="5" name="Picture 4" descr="slide_7_Picture 7.png"/>
           <p:cNvPicPr>
             <a:picLocks noChangeAspect="1"/>
           </p:cNvPicPr>
@@ -5229,8 +5274,8 @@
         </p:blipFill>
         <p:spPr>
           <a:xfrm>
-            <a:off x="2651760" y="1554480"/>
-            <a:ext cx="5954043" cy="4389120"/>
+            <a:off x="3118104" y="1508760"/>
+            <a:ext cx="6078086" cy="4480560"/>
           </a:xfrm>
           <a:prstGeom prst="rect">
             <a:avLst/>
@@ -5245,7 +5290,7 @@
         </p:nvSpPr>
         <p:spPr>
           <a:xfrm>
-            <a:off x="822960" y="6217920"/>
+            <a:off x="822960" y="6263640"/>
             <a:ext cx="10545775" cy="320040"/>
           </a:xfrm>
           <a:prstGeom prst="rect">
@@ -5262,7 +5307,7 @@
             <a:pPr algn="ctr">
               <a:defRPr sz="1100">
                 <a:solidFill>
-                  <a:srgbClr val="A1A1AA"/>
+                  <a:srgbClr val="64748B"/>
                 </a:solidFill>
                 <a:latin typeface="Arial"/>
               </a:defRPr>
@@ -5287,7 +5332,7 @@
     <p:bg>
       <p:bgPr>
         <a:solidFill>
-          <a:srgbClr val="000000"/>
+          <a:srgbClr val="FFFFFF"/>
         </a:solidFill>
         <a:effectLst/>
       </p:bgPr>
@@ -5324,7 +5369,7 @@
             <a:pPr>
               <a:defRPr sz="950" b="1">
                 <a:solidFill>
-                  <a:srgbClr val="A1A1AA"/>
+                  <a:srgbClr val="64748B"/>
                 </a:solidFill>
                 <a:latin typeface="Arial"/>
               </a:defRPr>
@@ -5360,7 +5405,7 @@
             <a:pPr>
               <a:defRPr sz="2400" b="1">
                 <a:solidFill>
-                  <a:srgbClr val="FFFFFF"/>
+                  <a:srgbClr val="0F172A"/>
                 </a:solidFill>
                 <a:latin typeface="Helvetica Neue"/>
               </a:defRPr>
@@ -5386,11 +5431,11 @@
             <a:avLst/>
           </a:prstGeom>
           <a:solidFill>
-            <a:srgbClr val="121214"/>
+            <a:srgbClr val="F8FAFC"/>
           </a:solidFill>
           <a:ln w="9525">
             <a:solidFill>
-              <a:srgbClr val="27272A"/>
+              <a:srgbClr val="E2E8F0"/>
             </a:solidFill>
           </a:ln>
         </p:spPr>
@@ -5441,7 +5486,7 @@
             <a:pPr>
               <a:defRPr sz="1200" b="1">
                 <a:solidFill>
-                  <a:srgbClr val="E4E4E7"/>
+                  <a:srgbClr val="334155"/>
                 </a:solidFill>
                 <a:latin typeface="Arial"/>
               </a:defRPr>
@@ -5457,7 +5502,7 @@
               </a:spcBef>
               <a:defRPr sz="1600" b="1">
                 <a:solidFill>
-                  <a:srgbClr val="FFFFFF"/>
+                  <a:srgbClr val="0F172A"/>
                 </a:solidFill>
                 <a:latin typeface="Helvetica Neue"/>
               </a:defRPr>
@@ -5473,7 +5518,7 @@
               </a:spcBef>
               <a:defRPr sz="1050">
                 <a:solidFill>
-                  <a:srgbClr val="A1A1AA"/>
+                  <a:srgbClr val="64748B"/>
                 </a:solidFill>
                 <a:latin typeface="Courier New"/>
               </a:defRPr>
@@ -5499,11 +5544,11 @@
             <a:avLst/>
           </a:prstGeom>
           <a:solidFill>
-            <a:srgbClr val="121214"/>
+            <a:srgbClr val="F8FAFC"/>
           </a:solidFill>
           <a:ln w="9525">
             <a:solidFill>
-              <a:srgbClr val="27272A"/>
+              <a:srgbClr val="E2E8F0"/>
             </a:solidFill>
           </a:ln>
         </p:spPr>
@@ -5554,7 +5599,7 @@
             <a:pPr>
               <a:defRPr sz="1200" b="1">
                 <a:solidFill>
-                  <a:srgbClr val="E4E4E7"/>
+                  <a:srgbClr val="334155"/>
                 </a:solidFill>
                 <a:latin typeface="Arial"/>
               </a:defRPr>
@@ -5570,7 +5615,7 @@
               </a:spcBef>
               <a:defRPr sz="1600" b="1">
                 <a:solidFill>
-                  <a:srgbClr val="FFFFFF"/>
+                  <a:srgbClr val="0F172A"/>
                 </a:solidFill>
                 <a:latin typeface="Helvetica Neue"/>
               </a:defRPr>
@@ -5586,7 +5631,7 @@
               </a:spcBef>
               <a:defRPr sz="1050">
                 <a:solidFill>
-                  <a:srgbClr val="A1A1AA"/>
+                  <a:srgbClr val="64748B"/>
                 </a:solidFill>
                 <a:latin typeface="Courier New"/>
               </a:defRPr>

</xml_diff>

<commit_message>
Add explicit Raymer takeoff weight sizing calculation and mass breakdown to Slide 6
</commit_message>
<xml_diff>
--- a/Aircraft_Design_DT1_EXAELIA_Group13.pptx
+++ b/Aircraft_Design_DT1_EXAELIA_Group13.pptx
@@ -4732,7 +4732,7 @@
               </a:defRPr>
             </a:pPr>
             <a:r>
-              <a:t>MTOW</a:t>
+              <a:t>MTOW &amp; Mass Sizing</a:t>
             </a:r>
           </a:p>
         </p:txBody>
@@ -4745,8 +4745,8 @@
         </p:nvSpPr>
         <p:spPr>
           <a:xfrm>
-            <a:off x="822960" y="1371600"/>
-            <a:ext cx="3413455" cy="4572000"/>
+            <a:off x="822960" y="1325880"/>
+            <a:ext cx="10545775" cy="1600200"/>
           </a:xfrm>
           <a:prstGeom prst="roundRect">
             <a:avLst/>
@@ -4790,8 +4790,8 @@
         </p:nvSpPr>
         <p:spPr>
           <a:xfrm>
-            <a:off x="1143000" y="1737360"/>
-            <a:ext cx="2743200" cy="3840480"/>
+            <a:off x="1097280" y="1463040"/>
+            <a:ext cx="10058400" cy="1325880"/>
           </a:xfrm>
           <a:prstGeom prst="rect">
             <a:avLst/>
@@ -4799,13 +4799,13 @@
           <a:noFill/>
         </p:spPr>
         <p:txBody>
-          <a:bodyPr wrap="none">
+          <a:bodyPr wrap="square">
             <a:spAutoFit/>
           </a:bodyPr>
           <a:lstStyle/>
           <a:p>
             <a:pPr>
-              <a:defRPr sz="1100" b="1">
+              <a:defRPr sz="1050" b="1">
                 <a:solidFill>
                   <a:srgbClr val="64748B"/>
                 </a:solidFill>
@@ -4813,15 +4813,15 @@
               </a:defRPr>
             </a:pPr>
             <a:r>
-              <a:t>ASSUMPTION</a:t>
+              <a:t>TAKEOFF WEIGHT SIZING EQUATION (RAYMER METHOD)</a:t>
             </a:r>
           </a:p>
           <a:p>
             <a:pPr>
               <a:spcBef>
-                <a:spcPts val="800"/>
+                <a:spcPts val="300"/>
               </a:spcBef>
-              <a:defRPr sz="2600" b="1">
+              <a:defRPr sz="1700" b="1">
                 <a:solidFill>
                   <a:srgbClr val="0F172A"/>
                 </a:solidFill>
@@ -4829,15 +4829,15 @@
               </a:defRPr>
             </a:pPr>
             <a:r>
-              <a:t>Aircraft design book</a:t>
+              <a:t>W0 = ( W_payload + W_crew )  /  [ 1 − ( We / W0 ) − ( Wf / W0 ) ]</a:t>
             </a:r>
           </a:p>
           <a:p>
             <a:pPr>
               <a:spcBef>
-                <a:spcPts val="600"/>
+                <a:spcPts val="400"/>
               </a:spcBef>
-              <a:defRPr sz="1350" b="1">
+              <a:defRPr sz="1400" b="1">
                 <a:solidFill>
                   <a:srgbClr val="334155"/>
                 </a:solidFill>
@@ -4845,23 +4845,7 @@
               </a:defRPr>
             </a:pPr>
             <a:r>
-              <a:t>Raymer statistical empty weight buildup method</a:t>
-            </a:r>
-          </a:p>
-          <a:p>
-            <a:pPr>
-              <a:spcBef>
-                <a:spcPts val="2600"/>
-              </a:spcBef>
-              <a:defRPr sz="1100">
-                <a:solidFill>
-                  <a:srgbClr val="94A3B8"/>
-                </a:solidFill>
-                <a:latin typeface="Arial"/>
-              </a:defRPr>
-            </a:pPr>
-            <a:r>
-              <a:t>Raymer Methodology</a:t>
+              <a:t>W0 = ( 53,750 kg + 1,260 kg )  /  [ 1 − 0.565 − 0.235 ]  =  55,010 kg / 0.200  =  275,460 kg  (~275.5 t)</a:t>
             </a:r>
           </a:p>
         </p:txBody>
@@ -4874,8 +4858,8 @@
         </p:nvSpPr>
         <p:spPr>
           <a:xfrm>
-            <a:off x="4389120" y="1371600"/>
-            <a:ext cx="3413455" cy="4572000"/>
+            <a:off x="822960" y="3108960"/>
+            <a:ext cx="2542032" cy="3017520"/>
           </a:xfrm>
           <a:prstGeom prst="roundRect">
             <a:avLst/>
@@ -4919,8 +4903,8 @@
         </p:nvSpPr>
         <p:spPr>
           <a:xfrm>
-            <a:off x="4709160" y="1737360"/>
-            <a:ext cx="2743200" cy="3840480"/>
+            <a:off x="1051560" y="3383280"/>
+            <a:ext cx="2103120" cy="2560320"/>
           </a:xfrm>
           <a:prstGeom prst="rect">
             <a:avLst/>
@@ -4928,21 +4912,53 @@
           <a:noFill/>
         </p:spPr>
         <p:txBody>
-          <a:bodyPr wrap="none">
+          <a:bodyPr wrap="square">
             <a:spAutoFit/>
           </a:bodyPr>
           <a:lstStyle/>
           <a:p>
             <a:pPr>
+              <a:defRPr sz="1000" b="1">
+                <a:solidFill>
+                  <a:srgbClr val="64748B"/>
+                </a:solidFill>
+                <a:latin typeface="Arial"/>
+              </a:defRPr>
+            </a:pPr>
+            <a:r>
+              <a:t>EMPTY WEIGHT (We)</a:t>
+            </a:r>
+          </a:p>
+          <a:p>
+            <a:pPr>
+              <a:spcBef>
+                <a:spcPts val="400"/>
+              </a:spcBef>
+              <a:defRPr sz="2200" b="1">
+                <a:solidFill>
+                  <a:srgbClr val="0F172A"/>
+                </a:solidFill>
+                <a:latin typeface="Helvetica Neue"/>
+              </a:defRPr>
+            </a:pPr>
+            <a:r>
+              <a:t>155,600 kg</a:t>
+            </a:r>
+          </a:p>
+          <a:p>
+            <a:pPr>
+              <a:spcBef>
+                <a:spcPts val="200"/>
+              </a:spcBef>
               <a:defRPr sz="1100" b="1">
                 <a:solidFill>
-                  <a:srgbClr val="64748B"/>
-                </a:solidFill>
-                <a:latin typeface="Arial"/>
-              </a:defRPr>
-            </a:pPr>
-            <a:r>
-              <a:t>EMPTY WEIGHT FRACTION</a:t>
+                  <a:srgbClr val="334155"/>
+                </a:solidFill>
+                <a:latin typeface="Helvetica Neue"/>
+              </a:defRPr>
+            </a:pPr>
+            <a:r>
+              <a:t>We / W0 = 0.56 (56.5%)</a:t>
             </a:r>
           </a:p>
           <a:p>
@@ -4950,47 +4966,19 @@
               <a:spcBef>
                 <a:spcPts val="800"/>
               </a:spcBef>
-              <a:defRPr sz="3800" b="1">
-                <a:solidFill>
-                  <a:srgbClr val="0F172A"/>
-                </a:solidFill>
-                <a:latin typeface="Helvetica Neue"/>
-              </a:defRPr>
-            </a:pPr>
-            <a:r>
-              <a:t>0.56</a:t>
-            </a:r>
-          </a:p>
-          <a:p>
-            <a:pPr>
-              <a:spcBef>
-                <a:spcPts val="600"/>
-              </a:spcBef>
-              <a:defRPr sz="1350" b="1">
-                <a:solidFill>
-                  <a:srgbClr val="334155"/>
-                </a:solidFill>
-                <a:latin typeface="Helvetica Neue"/>
-              </a:defRPr>
-            </a:pPr>
-            <a:r>
-              <a:t>We / W0 = 155,600 / 275,460 kg</a:t>
-            </a:r>
-          </a:p>
-          <a:p>
-            <a:pPr>
-              <a:spcBef>
-                <a:spcPts val="2600"/>
-              </a:spcBef>
-              <a:defRPr sz="1100">
-                <a:solidFill>
-                  <a:srgbClr val="94A3B8"/>
+              <a:defRPr sz="1000">
+                <a:solidFill>
+                  <a:srgbClr val="64748B"/>
                 </a:solidFill>
                 <a:latin typeface="Arial"/>
               </a:defRPr>
             </a:pPr>
             <a:r>
-              <a:t>MTOW = 275,460 kg (~275.5 t)</a:t>
+              <a:t>Airframe: 120,200 kg (43.6%)</a:t>
+            </a:r>
+            <a:br/>
+            <a:r>
+              <a:t>Tanks: 35,400 kg (6 × 5,900 kg)</a:t>
             </a:r>
           </a:p>
         </p:txBody>
@@ -5003,8 +4991,8 @@
         </p:nvSpPr>
         <p:spPr>
           <a:xfrm>
-            <a:off x="7955279" y="1371600"/>
-            <a:ext cx="3413455" cy="4572000"/>
+            <a:off x="3493008" y="3108960"/>
+            <a:ext cx="2542032" cy="3017520"/>
           </a:xfrm>
           <a:prstGeom prst="roundRect">
             <a:avLst/>
@@ -5048,8 +5036,8 @@
         </p:nvSpPr>
         <p:spPr>
           <a:xfrm>
-            <a:off x="8275319" y="1737360"/>
-            <a:ext cx="2743200" cy="3840480"/>
+            <a:off x="3721608" y="3383280"/>
+            <a:ext cx="2103120" cy="2560320"/>
           </a:xfrm>
           <a:prstGeom prst="rect">
             <a:avLst/>
@@ -5057,21 +5045,53 @@
           <a:noFill/>
         </p:spPr>
         <p:txBody>
-          <a:bodyPr wrap="none">
+          <a:bodyPr wrap="square">
             <a:spAutoFit/>
           </a:bodyPr>
           <a:lstStyle/>
           <a:p>
             <a:pPr>
+              <a:defRPr sz="1000" b="1">
+                <a:solidFill>
+                  <a:srgbClr val="64748B"/>
+                </a:solidFill>
+                <a:latin typeface="Arial"/>
+              </a:defRPr>
+            </a:pPr>
+            <a:r>
+              <a:t>DESIGN PAYLOAD</a:t>
+            </a:r>
+          </a:p>
+          <a:p>
+            <a:pPr>
+              <a:spcBef>
+                <a:spcPts val="400"/>
+              </a:spcBef>
+              <a:defRPr sz="2200" b="1">
+                <a:solidFill>
+                  <a:srgbClr val="0F172A"/>
+                </a:solidFill>
+                <a:latin typeface="Helvetica Neue"/>
+              </a:defRPr>
+            </a:pPr>
+            <a:r>
+              <a:t>53,750 kg</a:t>
+            </a:r>
+          </a:p>
+          <a:p>
+            <a:pPr>
+              <a:spcBef>
+                <a:spcPts val="200"/>
+              </a:spcBef>
               <a:defRPr sz="1100" b="1">
                 <a:solidFill>
-                  <a:srgbClr val="64748B"/>
-                </a:solidFill>
-                <a:latin typeface="Arial"/>
-              </a:defRPr>
-            </a:pPr>
-            <a:r>
-              <a:t>TANK MASS</a:t>
+                  <a:srgbClr val="334155"/>
+                </a:solidFill>
+                <a:latin typeface="Helvetica Neue"/>
+              </a:defRPr>
+            </a:pPr>
+            <a:r>
+              <a:t>19.5% of MTOW</a:t>
             </a:r>
           </a:p>
           <a:p>
@@ -5079,47 +5099,321 @@
               <a:spcBef>
                 <a:spcPts val="800"/>
               </a:spcBef>
-              <a:defRPr sz="3800" b="1">
-                <a:solidFill>
-                  <a:srgbClr val="0F172A"/>
-                </a:solidFill>
-                <a:latin typeface="Helvetica Neue"/>
-              </a:defRPr>
-            </a:pPr>
-            <a:r>
-              <a:t>35,400 kg</a:t>
+              <a:defRPr sz="1000">
+                <a:solidFill>
+                  <a:srgbClr val="64748B"/>
+                </a:solidFill>
+                <a:latin typeface="Arial"/>
+              </a:defRPr>
+            </a:pPr>
+            <a:r>
+              <a:t>430 Pax @ 100 kg = 43,000 kg</a:t>
+            </a:r>
+            <a:br/>
+            <a:r>
+              <a:t>Containerized Cargo = 10,750 kg</a:t>
+            </a:r>
+          </a:p>
+        </p:txBody>
+      </p:sp>
+      <p:sp>
+        <p:nvSpPr>
+          <p:cNvPr id="10" name="Rounded Rectangle 9"/>
+          <p:cNvSpPr/>
+          <p:nvPr/>
+        </p:nvSpPr>
+        <p:spPr>
+          <a:xfrm>
+            <a:off x="6163056" y="3108960"/>
+            <a:ext cx="2542032" cy="3017520"/>
+          </a:xfrm>
+          <a:prstGeom prst="roundRect">
+            <a:avLst/>
+          </a:prstGeom>
+          <a:solidFill>
+            <a:srgbClr val="F8FAFC"/>
+          </a:solidFill>
+          <a:ln w="9525">
+            <a:solidFill>
+              <a:srgbClr val="E2E8F0"/>
+            </a:solidFill>
+          </a:ln>
+        </p:spPr>
+        <p:style>
+          <a:lnRef idx="1">
+            <a:schemeClr val="accent1"/>
+          </a:lnRef>
+          <a:fillRef idx="3">
+            <a:schemeClr val="accent1"/>
+          </a:fillRef>
+          <a:effectRef idx="2">
+            <a:schemeClr val="accent1"/>
+          </a:effectRef>
+          <a:fontRef idx="minor">
+            <a:schemeClr val="lt1"/>
+          </a:fontRef>
+        </p:style>
+        <p:txBody>
+          <a:bodyPr rtlCol="0" anchor="ctr"/>
+          <a:lstStyle/>
+          <a:p>
+            <a:pPr algn="ctr"/>
+          </a:p>
+        </p:txBody>
+      </p:sp>
+      <p:sp>
+        <p:nvSpPr>
+          <p:cNvPr id="11" name="TextBox 10"/>
+          <p:cNvSpPr txBox="1"/>
+          <p:nvPr/>
+        </p:nvSpPr>
+        <p:spPr>
+          <a:xfrm>
+            <a:off x="6391656" y="3383280"/>
+            <a:ext cx="2103120" cy="2560320"/>
+          </a:xfrm>
+          <a:prstGeom prst="rect">
+            <a:avLst/>
+          </a:prstGeom>
+          <a:noFill/>
+        </p:spPr>
+        <p:txBody>
+          <a:bodyPr wrap="square">
+            <a:spAutoFit/>
+          </a:bodyPr>
+          <a:lstStyle/>
+          <a:p>
+            <a:pPr>
+              <a:defRPr sz="1000" b="1">
+                <a:solidFill>
+                  <a:srgbClr val="64748B"/>
+                </a:solidFill>
+                <a:latin typeface="Arial"/>
+              </a:defRPr>
+            </a:pPr>
+            <a:r>
+              <a:t>MISSION LH2 FUEL</a:t>
             </a:r>
           </a:p>
           <a:p>
             <a:pPr>
               <a:spcBef>
-                <a:spcPts val="600"/>
+                <a:spcPts val="400"/>
               </a:spcBef>
-              <a:defRPr sz="1350" b="1">
-                <a:solidFill>
-                  <a:srgbClr val="334155"/>
+              <a:defRPr sz="2200" b="1">
+                <a:solidFill>
+                  <a:srgbClr val="0F172A"/>
                 </a:solidFill>
                 <a:latin typeface="Helvetica Neue"/>
               </a:defRPr>
             </a:pPr>
             <a:r>
-              <a:t>6 tanks × 5,900 kg</a:t>
+              <a:t>64,850 kg</a:t>
             </a:r>
           </a:p>
           <a:p>
             <a:pPr>
               <a:spcBef>
-                <a:spcPts val="2600"/>
+                <a:spcPts val="200"/>
               </a:spcBef>
-              <a:defRPr sz="1100">
-                <a:solidFill>
-                  <a:srgbClr val="94A3B8"/>
+              <a:defRPr sz="1100" b="1">
+                <a:solidFill>
+                  <a:srgbClr val="334155"/>
+                </a:solidFill>
+                <a:latin typeface="Helvetica Neue"/>
+              </a:defRPr>
+            </a:pPr>
+            <a:r>
+              <a:t>Wf / W0 = 0.235 (23.5%)</a:t>
+            </a:r>
+          </a:p>
+          <a:p>
+            <a:pPr>
+              <a:spcBef>
+                <a:spcPts val="800"/>
+              </a:spcBef>
+              <a:defRPr sz="1000">
+                <a:solidFill>
+                  <a:srgbClr val="64748B"/>
                 </a:solidFill>
                 <a:latin typeface="Arial"/>
               </a:defRPr>
             </a:pPr>
             <a:r>
-              <a:t>Gravimetric index Gi = 0.50</a:t>
+              <a:t>Breguet cruise (12,500 km)</a:t>
+            </a:r>
+            <a:br/>
+            <a:r>
+              <a:t>200 nm diversion + 30 min loiter</a:t>
+            </a:r>
+          </a:p>
+        </p:txBody>
+      </p:sp>
+      <p:sp>
+        <p:nvSpPr>
+          <p:cNvPr id="12" name="Rounded Rectangle 11"/>
+          <p:cNvSpPr/>
+          <p:nvPr/>
+        </p:nvSpPr>
+        <p:spPr>
+          <a:xfrm>
+            <a:off x="8833104" y="3108960"/>
+            <a:ext cx="2542032" cy="3017520"/>
+          </a:xfrm>
+          <a:prstGeom prst="roundRect">
+            <a:avLst/>
+          </a:prstGeom>
+          <a:solidFill>
+            <a:srgbClr val="F8FAFC"/>
+          </a:solidFill>
+          <a:ln w="9525">
+            <a:solidFill>
+              <a:srgbClr val="E2E8F0"/>
+            </a:solidFill>
+          </a:ln>
+        </p:spPr>
+        <p:style>
+          <a:lnRef idx="1">
+            <a:schemeClr val="accent1"/>
+          </a:lnRef>
+          <a:fillRef idx="3">
+            <a:schemeClr val="accent1"/>
+          </a:fillRef>
+          <a:effectRef idx="2">
+            <a:schemeClr val="accent1"/>
+          </a:effectRef>
+          <a:fontRef idx="minor">
+            <a:schemeClr val="lt1"/>
+          </a:fontRef>
+        </p:style>
+        <p:txBody>
+          <a:bodyPr rtlCol="0" anchor="ctr"/>
+          <a:lstStyle/>
+          <a:p>
+            <a:pPr algn="ctr"/>
+          </a:p>
+        </p:txBody>
+      </p:sp>
+      <p:sp>
+        <p:nvSpPr>
+          <p:cNvPr id="13" name="TextBox 12"/>
+          <p:cNvSpPr txBox="1"/>
+          <p:nvPr/>
+        </p:nvSpPr>
+        <p:spPr>
+          <a:xfrm>
+            <a:off x="9061704" y="3383280"/>
+            <a:ext cx="2103120" cy="2560320"/>
+          </a:xfrm>
+          <a:prstGeom prst="rect">
+            <a:avLst/>
+          </a:prstGeom>
+          <a:noFill/>
+        </p:spPr>
+        <p:txBody>
+          <a:bodyPr wrap="square">
+            <a:spAutoFit/>
+          </a:bodyPr>
+          <a:lstStyle/>
+          <a:p>
+            <a:pPr>
+              <a:defRPr sz="1000" b="1">
+                <a:solidFill>
+                  <a:srgbClr val="64748B"/>
+                </a:solidFill>
+                <a:latin typeface="Arial"/>
+              </a:defRPr>
+            </a:pPr>
+            <a:r>
+              <a:t>FLIGHT CREW</a:t>
+            </a:r>
+          </a:p>
+          <a:p>
+            <a:pPr>
+              <a:spcBef>
+                <a:spcPts val="400"/>
+              </a:spcBef>
+              <a:defRPr sz="2200" b="1">
+                <a:solidFill>
+                  <a:srgbClr val="0F172A"/>
+                </a:solidFill>
+                <a:latin typeface="Helvetica Neue"/>
+              </a:defRPr>
+            </a:pPr>
+            <a:r>
+              <a:t>1,260 kg</a:t>
+            </a:r>
+          </a:p>
+          <a:p>
+            <a:pPr>
+              <a:spcBef>
+                <a:spcPts val="200"/>
+              </a:spcBef>
+              <a:defRPr sz="1100" b="1">
+                <a:solidFill>
+                  <a:srgbClr val="334155"/>
+                </a:solidFill>
+                <a:latin typeface="Helvetica Neue"/>
+              </a:defRPr>
+            </a:pPr>
+            <a:r>
+              <a:t>0.5% of MTOW</a:t>
+            </a:r>
+          </a:p>
+          <a:p>
+            <a:pPr>
+              <a:spcBef>
+                <a:spcPts val="800"/>
+              </a:spcBef>
+              <a:defRPr sz="1000">
+                <a:solidFill>
+                  <a:srgbClr val="64748B"/>
+                </a:solidFill>
+                <a:latin typeface="Arial"/>
+              </a:defRPr>
+            </a:pPr>
+            <a:r>
+              <a:t>2 Flight Deck Pilots</a:t>
+            </a:r>
+            <a:br/>
+            <a:r>
+              <a:t>10 Cabin Crew Attendants</a:t>
+            </a:r>
+          </a:p>
+        </p:txBody>
+      </p:sp>
+      <p:sp>
+        <p:nvSpPr>
+          <p:cNvPr id="14" name="TextBox 13"/>
+          <p:cNvSpPr txBox="1"/>
+          <p:nvPr/>
+        </p:nvSpPr>
+        <p:spPr>
+          <a:xfrm>
+            <a:off x="822960" y="6263640"/>
+            <a:ext cx="10545775" cy="320040"/>
+          </a:xfrm>
+          <a:prstGeom prst="rect">
+            <a:avLst/>
+          </a:prstGeom>
+          <a:noFill/>
+        </p:spPr>
+        <p:txBody>
+          <a:bodyPr wrap="none">
+            <a:spAutoFit/>
+          </a:bodyPr>
+          <a:lstStyle/>
+          <a:p>
+            <a:pPr algn="ctr">
+              <a:defRPr sz="1050">
+                <a:solidFill>
+                  <a:srgbClr val="64748B"/>
+                </a:solidFill>
+                <a:latin typeface="Arial"/>
+              </a:defRPr>
+            </a:pPr>
+            <a:r>
+              <a:t>Cryotank Gravimetric Index Gi = 0.50 (M_tank = M_fuel)  •  Raymer Statistical Empty Weight Sizing</a:t>
             </a:r>
           </a:p>
         </p:txBody>

</xml_diff>